<commit_message>
docs: refresh slides and demo guide with Jenkins evidence
</commit_message>
<xml_diff>
--- a/docs/presentation/devasc-overview.pptx
+++ b/docs/presentation/devasc-overview.pptx
@@ -513,7 +513,7 @@
           <a:lstStyle/>
           <a:p>
             <a:r>
-              <a:t>Introduce the project as an enhancement of the supplied lab. This is a team project; do not claim that the group wrote the routing engine. Instructor scope approval and the required Jenkins evidence remain pending.</a:t>
+              <a:t>Introduce the project as an enhancement of the supplied lab. This is a team project; do not claim that the group wrote the routing engine. Jenkins success, SCM triggering, failure/recovery and final-main build #5 are verified. Instructor scope/polling acceptance and actual team assessment remain pending.</a:t>
             </a:r>
           </a:p>
         </p:txBody>
@@ -583,7 +583,7 @@
           <a:lstStyle/>
           <a:p>
             <a:r>
-              <a:t>Explain that GraphHopper provides routes while Jenkins tests the code. GitHub Actions is verified but supplementary. The local Jenkins package is prepared in a separate PR, not a running/verified service. Merge it, configure checkout credentials in Jenkins, run the job once and record real build evidence. Do not claim polling is a verified GitHub webhook.</a:t>
+              <a:t>Jenkins 2.580.1 is running. Original #1 passed manually, and SCM polling started #2 automatically. On the separate demo job, #1 at bdd74ce failed exactly one intentional test; reverting only that test produced ed43bde and automatic Demo #2 passed 69 tests. After PRs #30/#28 merged, original build #5 checked out c6d34d5 and passed 69 tests in 0.486 seconds with its report archived. The original job targets main and the demo job is disabled with its history retained. Open the saved failure/recovery/main reports and screenshots. See docs/jenkins-evidence.md and handoff PR #32. Polling is verified; webhook delivery and instructor acceptance are not.</a:t>
             </a:r>
           </a:p>
         </p:txBody>
@@ -723,7 +723,7 @@
           <a:lstStyle/>
           <a:p>
             <a:r>
-              <a:t>Supporting local materials: docs/final-report.md and docs/test-results.md (final report PR); docs/demo-guide.md; docs/team-reflection.md; docs/jenkins-local-setup.md (Jenkins PR); docs/live-verification.md. Also use the supplied DEVASC Project.pdf and REST API lab. All four documentation/setup PRs should be reviewed and merged before using repository-relative links as a final submission.</a:t>
+              <a:t>Supporting local materials: docs/final-report.md and docs/test-results.md (final report PR); docs/demo-guide.md; docs/team-reflection.md; docs/jenkins-local-setup.md (Jenkins PR); docs/live-verification.md. Also use the supplied DEVASC Project.pdf and REST API lab. PRs #28/#30 are merged. Report PR #29, presentation PR #31 and shared handoff PR #32 still need review/merge. Build #5 verified main at c6d34d5; do not describe later documentation as already merged.</a:t>
             </a:r>
           </a:p>
         </p:txBody>
@@ -1143,7 +1143,7 @@
           <a:lstStyle/>
           <a:p>
             <a:r>
-              <a:t>Run python scripts/run_offline_tests.py. The runner clears the real key, disables dotenv loading and blocks unmocked HTTP/socket connections. Failure and empty discovery return nonzero status. Merged-main run: https://github.com/FlimsyOwl12/DEVASC-Project/actions/runs/39121848255 .</a:t>
+              <a:t>Run python scripts/run_offline_tests.py. The runner clears the real key, disables dotenv loading and blocks unmocked HTTP/socket connections. Failure and empty discovery return nonzero status. Merged-main run: https://github.com/FlimsyOwl12/DEVASC-Project/actions/runs/39132132376 .</a:t>
             </a:r>
           </a:p>
         </p:txBody>
@@ -4982,7 +4982,7 @@
                 </a:solidFill>
                 <a:latin typeface="Arial"/>
               </a:rPr>
-              <a:t>SCM polling supports local Jenkins; a webhook needs a reachable server.</a:t>
+              <a:t>SCM polling started original build #2 and Demo recovery #2. Webhook delivery is unverified.</a:t>
             </a:r>
           </a:p>
         </p:txBody>
@@ -5064,7 +5064,7 @@
                 </a:solidFill>
                 <a:latin typeface="Arial"/>
               </a:rPr>
-              <a:t>Prepared setup</a:t>
+              <a:t>Failure and recovery</a:t>
             </a:r>
           </a:p>
         </p:txBody>
@@ -5103,7 +5103,7 @@
                 </a:solidFill>
                 <a:latin typeface="Arial"/>
               </a:rPr>
-              <a:t>Local Docker/Compose package, Python/venv and required Jenkins plugins.</a:t>
+              <a:t>Demo #1: 70 tests, one intentional failure. Demo #2: 69 passing tests.</a:t>
             </a:r>
           </a:p>
         </p:txBody>
@@ -5185,7 +5185,7 @@
                 </a:solidFill>
                 <a:latin typeface="Arial"/>
               </a:rPr>
-              <a:t>Still to verify</a:t>
+              <a:t>Main verified</a:t>
             </a:r>
           </a:p>
         </p:txBody>
@@ -5224,7 +5224,7 @@
                 </a:solidFill>
                 <a:latin typeface="Arial"/>
               </a:rPr>
-              <a:t>Real success, deliberate failure, recovery and new-commit trigger evidence.</a:t>
+              <a:t>Build #5 at c6d34d5: 69 tests passed, report archived, SUCCESS.</a:t>
             </a:r>
           </a:p>
         </p:txBody>
@@ -6232,7 +6232,7 @@
                 <a:latin typeface="Arial"/>
                 <a:hlinkClick r:id="rId4"/>
               </a:rPr>
-              <a:t>https://github.com/FlimsyOwl12/DEVASC-Project/actions/runs/39121848255</a:t>
+              <a:t>https://github.com/FlimsyOwl12/DEVASC-Project/actions/runs/39132132376</a:t>
             </a:r>
           </a:p>
         </p:txBody>
@@ -6393,6 +6393,86 @@
                 <a:hlinkClick r:id="rId6"/>
               </a:rPr>
               <a:t>https://github.com/Cocoasaur/devasc-graphhopper-api/tree/2289d4d</a:t>
+            </a:r>
+          </a:p>
+        </p:txBody>
+      </p:sp>
+      <p:sp>
+        <p:nvSpPr>
+          <p:cNvPr id="14" name="TextBox 13"/>
+          <p:cNvSpPr txBox="1"/>
+          <p:nvPr/>
+        </p:nvSpPr>
+        <p:spPr>
+          <a:xfrm>
+            <a:off x="777240" y="5577840"/>
+            <a:ext cx="10607040" cy="457200"/>
+          </a:xfrm>
+          <a:prstGeom prst="rect">
+            <a:avLst/>
+          </a:prstGeom>
+          <a:noFill/>
+        </p:spPr>
+        <p:txBody>
+          <a:bodyPr wrap="square" lIns="0" rIns="0" tIns="0" bIns="0">
+            <a:spAutoFit/>
+          </a:bodyPr>
+          <a:lstStyle/>
+          <a:p>
+            <a:pPr>
+              <a:spcAft>
+                <a:spcPts val="600"/>
+              </a:spcAft>
+            </a:pPr>
+            <a:r>
+              <a:rPr sz="2400" b="1">
+                <a:solidFill>
+                  <a:srgbClr val="087F78"/>
+                </a:solidFill>
+                <a:latin typeface="Arial"/>
+                <a:hlinkClick r:id="rId7"/>
+              </a:rPr>
+              <a:t>Jenkins build record / local links inside</a:t>
+            </a:r>
+          </a:p>
+        </p:txBody>
+      </p:sp>
+      <p:sp>
+        <p:nvSpPr>
+          <p:cNvPr id="15" name="TextBox 14"/>
+          <p:cNvSpPr txBox="1"/>
+          <p:nvPr/>
+        </p:nvSpPr>
+        <p:spPr>
+          <a:xfrm>
+            <a:off x="777240" y="6053327"/>
+            <a:ext cx="10607040" cy="320040"/>
+          </a:xfrm>
+          <a:prstGeom prst="rect">
+            <a:avLst/>
+          </a:prstGeom>
+          <a:noFill/>
+        </p:spPr>
+        <p:txBody>
+          <a:bodyPr wrap="square" lIns="0" rIns="0" tIns="0" bIns="0">
+            <a:spAutoFit/>
+          </a:bodyPr>
+          <a:lstStyle/>
+          <a:p>
+            <a:pPr>
+              <a:spcAft>
+                <a:spcPts val="600"/>
+              </a:spcAft>
+            </a:pPr>
+            <a:r>
+              <a:rPr sz="1300" b="0">
+                <a:solidFill>
+                  <a:srgbClr val="526574"/>
+                </a:solidFill>
+                <a:latin typeface="Arial"/>
+                <a:hlinkClick r:id="rId7"/>
+              </a:rPr>
+              <a:t>https://github.com/FlimsyOwl12/DEVASC-Project/blob/main/docs/jenkins-evidence.md</a:t>
             </a:r>
           </a:p>
         </p:txBody>
@@ -10329,7 +10409,7 @@
                 </a:solidFill>
                 <a:latin typeface="Arial"/>
               </a:rPr>
-              <a:t>Merged-main CI passed; Jenkins execution is still required.</a:t>
+              <a:t>GitHub CI + Jenkins main build #5: all 69 tests passed.</a:t>
             </a:r>
           </a:p>
         </p:txBody>

</xml_diff>